<commit_message>
Fix: correct how to add community skills (no /plugin install for a plain skills repo)
The prep step and §5 told trainers to run `/plugin install addyosmani/agent-skills`.
That does not work: `/plugin install` is a Copilot CLI command that only resolves
repos publishing a marketplace.json, and addyosmani/agent-skills is a Claude-Code
marketplace, not a Copilot one — so neither the CLI nor the app's default
marketplaces can find it.

Corrected across trainer-guide, slides (HTML + PPTX, kept 1:1), cheat-sheet (md+html)
and README:
- The Copilot app loads skills from a repo's `.github/skills/`; to use a community
  pack, clone it and copy the skill folders in (with `npx skills add ...` as a shortcut).
- Clarified that `/plugin install owner/repo` is Copilot-CLI-only and needs a
  marketplace repo; the app enables plugins via `.github/copilot/settings.json`.

Co-Authored-By: Claude Opus 4.8 <noreply@anthropic.com>
</commit_message>
<xml_diff>
--- a/slides/agentic-coding-101.pptx
+++ b/slides/agentic-coding-101.pptx
@@ -622,7 +622,7 @@
           <a:p>
             <a:r>
               <a:rPr lang="en-US" dirty="0"/>
-              <a:t>In the tour (0:10–0:25) we install Addy Osmani's agent-skills together so everyone has a shared, real library. Skills are the lightest customisation: a markdown file with frontmatter. Attendees author their own in Station 6.</a:t>
+              <a:t>In the tour (0:10–0:25) we add Addy Osmani's agent-skills together: clone the pack and copy a couple of skill folders into the repo's .github/skills/ (it is not a Copilot marketplace, so there is no /plugin install for it). Skills are the lightest customisation: a markdown file with frontmatter. Attendees author their own in Station 6.</a:t>
             </a:r>
             <a:endParaRPr lang="en-US" dirty="0"/>
           </a:p>
@@ -710,7 +710,7 @@
           <a:p>
             <a:r>
               <a:rPr lang="en-US" dirty="0"/>
-              <a:t>Plugins are how a bank platform team packages house rules and ships them to everyone with one install command. The demo-repo ships a sample security-reviewer.agent.md to show the shape of a custom agent.</a:t>
+              <a:t>Plugins are how a bank platform team packages house rules and ships them to everyone. Note the mechanism: /plugin install is a Copilot-CLI command and only resolves repos that publish a marketplace.json; the app enables plugins via .github/copilot/settings.json. The demo-repo ships a sample security-reviewer.agent.md to show the shape of a custom agent.</a:t>
             </a:r>
             <a:endParaRPr lang="en-US" dirty="0"/>
           </a:p>
@@ -4178,8 +4178,8 @@
         </p:nvSpPr>
         <p:spPr>
           <a:xfrm>
-            <a:off x="548640" y="2057400"/>
-            <a:ext cx="11094415" cy="2011680"/>
+            <a:off x="548640" y="2011680"/>
+            <a:ext cx="11094415" cy="2148840"/>
           </a:xfrm>
           <a:prstGeom prst="rect">
             <a:avLst/>
@@ -4193,13 +4193,13 @@
           <a:p>
             <a:pPr marL="203200" indent="-203200">
               <a:spcAft>
-                <a:spcPts val="800"/>
+                <a:spcPts val="700"/>
               </a:spcAft>
               <a:buSzPct val="100000"/>
               <a:buChar char="•"/>
             </a:pPr>
             <a:r>
-              <a:rPr lang="en-US" sz="1600" dirty="0">
+              <a:rPr lang="en-US" sz="1500" dirty="0">
                 <a:solidFill>
                   <a:srgbClr val="16233A"/>
                 </a:solidFill>
@@ -4209,18 +4209,18 @@
               </a:rPr>
               <a:t>A SKILL.md with YAML frontmatter (name, description).</a:t>
             </a:r>
-            <a:endParaRPr lang="en-US" sz="1600" dirty="0"/>
+            <a:endParaRPr lang="en-US" sz="1500" dirty="0"/>
           </a:p>
           <a:p>
             <a:pPr marL="203200" indent="-203200">
               <a:spcAft>
-                <a:spcPts val="800"/>
+                <a:spcPts val="700"/>
               </a:spcAft>
               <a:buSzPct val="100000"/>
               <a:buChar char="•"/>
             </a:pPr>
             <a:r>
-              <a:rPr lang="en-US" sz="1600" dirty="0">
+              <a:rPr lang="en-US" sz="1500" dirty="0">
                 <a:solidFill>
                   <a:srgbClr val="16233A"/>
                 </a:solidFill>
@@ -4230,18 +4230,18 @@
               </a:rPr>
               <a:t>Loaded on demand when the task matches.</a:t>
             </a:r>
-            <a:endParaRPr lang="en-US" sz="1600" dirty="0"/>
+            <a:endParaRPr lang="en-US" sz="1500" dirty="0"/>
           </a:p>
           <a:p>
             <a:pPr marL="203200" indent="-203200">
               <a:spcAft>
-                <a:spcPts val="800"/>
+                <a:spcPts val="700"/>
               </a:spcAft>
               <a:buSzPct val="100000"/>
               <a:buChar char="•"/>
             </a:pPr>
             <a:r>
-              <a:rPr lang="en-US" sz="1600" dirty="0">
+              <a:rPr lang="en-US" sz="1500" dirty="0">
                 <a:solidFill>
                   <a:srgbClr val="16233A"/>
                 </a:solidFill>
@@ -4251,7 +4251,28 @@
               </a:rPr>
               <a:t>Community: Addy Osmani agent-skills (24 lifecycle skills), Matt Pocock short-form skills, github/awesome-copilot.</a:t>
             </a:r>
-            <a:endParaRPr lang="en-US" sz="1600" dirty="0"/>
+            <a:endParaRPr lang="en-US" sz="1500" dirty="0"/>
+          </a:p>
+          <a:p>
+            <a:pPr marL="203200" indent="-203200">
+              <a:spcAft>
+                <a:spcPts val="700"/>
+              </a:spcAft>
+              <a:buSzPct val="100000"/>
+              <a:buChar char="•"/>
+            </a:pPr>
+            <a:r>
+              <a:rPr lang="en-US" sz="1500" dirty="0">
+                <a:solidFill>
+                  <a:srgbClr val="16233A"/>
+                </a:solidFill>
+                <a:latin typeface="Calibri" pitchFamily="34" charset="0"/>
+                <a:ea typeface="Calibri" pitchFamily="34" charset="-122"/>
+                <a:cs typeface="Calibri" pitchFamily="34" charset="-120"/>
+              </a:rPr>
+              <a:t>Add a pack: copy skill folders into .github/skills/ — no marketplace needed.</a:t>
+            </a:r>
+            <a:endParaRPr lang="en-US" sz="1500" dirty="0"/>
           </a:p>
         </p:txBody>
       </p:sp>
@@ -4263,12 +4284,12 @@
         </p:nvSpPr>
         <p:spPr>
           <a:xfrm>
-            <a:off x="548640" y="4297680"/>
-            <a:ext cx="11094415" cy="1280160"/>
+            <a:off x="548640" y="4343400"/>
+            <a:ext cx="11094415" cy="1234440"/>
           </a:xfrm>
           <a:prstGeom prst="roundRect">
             <a:avLst>
-              <a:gd name="adj" fmla="val 3571"/>
+              <a:gd name="adj" fmla="val 3704"/>
             </a:avLst>
           </a:prstGeom>
           <a:solidFill>
@@ -4290,8 +4311,8 @@
         </p:nvSpPr>
         <p:spPr>
           <a:xfrm>
-            <a:off x="676656" y="4343400"/>
-            <a:ext cx="10838383" cy="1188720"/>
+            <a:off x="676656" y="4389120"/>
+            <a:ext cx="10838383" cy="1143000"/>
           </a:xfrm>
           <a:prstGeom prst="rect">
             <a:avLst/>
@@ -4522,7 +4543,7 @@
         <p:spPr>
           <a:xfrm>
             <a:off x="548640" y="2194560"/>
-            <a:ext cx="11094415" cy="2743200"/>
+            <a:ext cx="11094415" cy="2926080"/>
           </a:xfrm>
           <a:prstGeom prst="rect">
             <a:avLst/>
@@ -4536,13 +4557,13 @@
           <a:p>
             <a:pPr marL="203200" indent="-203200">
               <a:spcAft>
-                <a:spcPts val="1200"/>
+                <a:spcPts val="1100"/>
               </a:spcAft>
               <a:buSzPct val="100000"/>
               <a:buChar char="•"/>
             </a:pPr>
             <a:r>
-              <a:rPr lang="en-US" sz="1800" dirty="0">
+              <a:rPr lang="en-US" sz="1700" dirty="0">
                 <a:solidFill>
                   <a:srgbClr val="16233A"/>
                 </a:solidFill>
@@ -4552,18 +4573,18 @@
               </a:rPr>
               <a:t>Custom agents: *.agent.md</a:t>
             </a:r>
-            <a:endParaRPr lang="en-US" sz="1800" dirty="0"/>
+            <a:endParaRPr lang="en-US" sz="1700" dirty="0"/>
           </a:p>
           <a:p>
             <a:pPr marL="203200" indent="-203200">
               <a:spcAft>
-                <a:spcPts val="1200"/>
+                <a:spcPts val="1100"/>
               </a:spcAft>
               <a:buSzPct val="100000"/>
               <a:buChar char="•"/>
             </a:pPr>
             <a:r>
-              <a:rPr lang="en-US" sz="1800" dirty="0">
+              <a:rPr lang="en-US" sz="1700" dirty="0">
                 <a:solidFill>
                   <a:srgbClr val="16233A"/>
                 </a:solidFill>
@@ -4573,18 +4594,18 @@
               </a:rPr>
               <a:t>Hooks: hooks.json · MCP: .mcp.json / mcp.json</a:t>
             </a:r>
-            <a:endParaRPr lang="en-US" sz="1800" dirty="0"/>
+            <a:endParaRPr lang="en-US" sz="1700" dirty="0"/>
           </a:p>
           <a:p>
             <a:pPr marL="203200" indent="-203200">
               <a:spcAft>
-                <a:spcPts val="1200"/>
+                <a:spcPts val="1100"/>
               </a:spcAft>
               <a:buSzPct val="100000"/>
               <a:buChar char="•"/>
             </a:pPr>
             <a:r>
-              <a:rPr lang="en-US" sz="1800" dirty="0">
+              <a:rPr lang="en-US" sz="1700" dirty="0">
                 <a:solidFill>
                   <a:srgbClr val="16233A"/>
                 </a:solidFill>
@@ -4592,9 +4613,30 @@
                 <a:ea typeface="Calibri" pitchFamily="34" charset="-122"/>
                 <a:cs typeface="Calibri" pitchFamily="34" charset="-120"/>
               </a:rPr>
-              <a:t>Install: /plugin install owner/repo</a:t>
-            </a:r>
-            <a:endParaRPr lang="en-US" sz="1800" dirty="0"/>
+              <a:t>Install: /plugin install owner/repo (Copilot CLI; repo must be a marketplace).</a:t>
+            </a:r>
+            <a:endParaRPr lang="en-US" sz="1700" dirty="0"/>
+          </a:p>
+          <a:p>
+            <a:pPr marL="203200" indent="-203200">
+              <a:spcAft>
+                <a:spcPts val="1100"/>
+              </a:spcAft>
+              <a:buSzPct val="100000"/>
+              <a:buChar char="•"/>
+            </a:pPr>
+            <a:r>
+              <a:rPr lang="en-US" sz="1700" dirty="0">
+                <a:solidFill>
+                  <a:srgbClr val="16233A"/>
+                </a:solidFill>
+                <a:latin typeface="Calibri" pitchFamily="34" charset="0"/>
+                <a:ea typeface="Calibri" pitchFamily="34" charset="-122"/>
+                <a:cs typeface="Calibri" pitchFamily="34" charset="-120"/>
+              </a:rPr>
+              <a:t>App enables plugins via .github/copilot/settings.json.</a:t>
+            </a:r>
+            <a:endParaRPr lang="en-US" sz="1700" dirty="0"/>
           </a:p>
         </p:txBody>
       </p:sp>

</xml_diff>

<commit_message>
§5 now demos the real marketplace path (agentic-coding-101-marketplace)
We published a real Copilot plugin marketplace, amilos/agentic-coding-101-marketplace,
bundling Addy Osmani's (24) and Matt Pocock's (39) skills as two plugins (MIT,
redistributed with attribution). §5 now shows the documented flow:

    /plugin marketplace add amilos/agentic-coding-101-marketplace
    /plugin install addyosmani-agent-skills@agentic-coding-101-marketplace
    /plugin install mattpocock-skills@agentic-coding-101-marketplace

Updated trainer-guide (prep + §5c live moment, with CLI-install and copy-into-
.github/skills fallbacks), slides (HTML + PPTX, kept 1:1 — 245/245 verbatim),
cheat-sheet (md+html) and README. Copy-into-.github/skills remains the no-CLI path.

Co-Authored-By: Claude Opus 4.8 <noreply@anthropic.com>
</commit_message>
<xml_diff>
--- a/slides/agentic-coding-101.pptx
+++ b/slides/agentic-coding-101.pptx
@@ -622,7 +622,7 @@
           <a:p>
             <a:r>
               <a:rPr lang="en-US" dirty="0"/>
-              <a:t>In the tour (0:10–0:25) we add Addy Osmani's agent-skills together: clone the pack and copy a couple of skill folders into the repo's .github/skills/ (it is not a Copilot marketplace, so there is no /plugin install for it). Skills are the lightest customisation: a markdown file with frontmatter. Attendees author their own in Station 6.</a:t>
+              <a:t>Two ways to get skills into a repo: drop folders under .github/skills/ (the app reads them), or install a plugin from a marketplace (next slide). In the tour (0:10–0:25) we install from our own marketplace, amilos/agentic-coding-101-marketplace, which bundles Addy Osmani's and Matt Pocock's packs. Attendees author their own in Station 6.</a:t>
             </a:r>
             <a:endParaRPr lang="en-US" dirty="0"/>
           </a:p>
@@ -710,7 +710,7 @@
           <a:p>
             <a:r>
               <a:rPr lang="en-US" dirty="0"/>
-              <a:t>Plugins are how a bank platform team packages house rules and ships them to everyone. Note the mechanism: /plugin install is a Copilot-CLI command and only resolves repos that publish a marketplace.json; the app enables plugins via .github/copilot/settings.json. The demo-repo ships a sample security-reviewer.agent.md to show the shape of a custom agent.</a:t>
+              <a:t>We publish a real marketplace, amilos/agentic-coding-101-marketplace, bundling Addy Osmani's (24) and Matt Pocock's (39) skills as two plugins — MIT, redistributed with attribution. Two commands and every session in the repo gains ~60 community skills. A plain skills repo is NOT a marketplace (no marketplace.json), which is why /plugin install owner/repo fails for those. The app can also enable plugins declaratively via .github/copilot/settings.json. The demo-repo ships a sample security-reviewer.agent.md to show the shape of a custom agent.</a:t>
             </a:r>
             <a:endParaRPr lang="en-US" dirty="0"/>
           </a:p>
@@ -4270,7 +4270,7 @@
                 <a:ea typeface="Calibri" pitchFamily="34" charset="-122"/>
                 <a:cs typeface="Calibri" pitchFamily="34" charset="-120"/>
               </a:rPr>
-              <a:t>Add a pack: copy skill folders into .github/skills/ — no marketplace needed.</a:t>
+              <a:t>Get them two ways: copy folders into .github/skills/, or install a plugin from a marketplace (next slide).</a:t>
             </a:r>
             <a:endParaRPr lang="en-US" sz="1500" dirty="0"/>
           </a:p>
@@ -4489,8 +4489,8 @@
         </p:nvSpPr>
         <p:spPr>
           <a:xfrm>
-            <a:off x="548640" y="1371600"/>
-            <a:ext cx="11094415" cy="502920"/>
+            <a:off x="548640" y="1325880"/>
+            <a:ext cx="11094415" cy="457200"/>
           </a:xfrm>
           <a:prstGeom prst="rect">
             <a:avLst/>
@@ -4506,7 +4506,7 @@
               <a:buNone/>
             </a:pPr>
             <a:r>
-              <a:rPr lang="en-US" sz="1800" b="1" dirty="0">
+              <a:rPr lang="en-US" sz="1700" b="1" dirty="0">
                 <a:solidFill>
                   <a:srgbClr val="1C5DC4"/>
                 </a:solidFill>
@@ -4520,7 +4520,7 @@
               <a:buNone/>
             </a:pPr>
             <a:r>
-              <a:rPr lang="en-US" sz="1800" dirty="0">
+              <a:rPr lang="en-US" sz="1700" dirty="0">
                 <a:solidFill>
                   <a:srgbClr val="16233A"/>
                 </a:solidFill>
@@ -4530,7 +4530,7 @@
               </a:rPr>
               <a:t> bundle custom agents, skills, hooks, MCP servers and LSP configs.</a:t>
             </a:r>
-            <a:endParaRPr lang="en-US" sz="1800" dirty="0"/>
+            <a:endParaRPr lang="en-US" sz="1700" dirty="0"/>
           </a:p>
         </p:txBody>
       </p:sp>
@@ -4542,8 +4542,8 @@
         </p:nvSpPr>
         <p:spPr>
           <a:xfrm>
-            <a:off x="548640" y="2194560"/>
-            <a:ext cx="11094415" cy="2926080"/>
+            <a:off x="548640" y="1920240"/>
+            <a:ext cx="11094415" cy="1417320"/>
           </a:xfrm>
           <a:prstGeom prst="rect">
             <a:avLst/>
@@ -4557,13 +4557,13 @@
           <a:p>
             <a:pPr marL="203200" indent="-203200">
               <a:spcAft>
-                <a:spcPts val="1100"/>
+                <a:spcPts val="900"/>
               </a:spcAft>
               <a:buSzPct val="100000"/>
               <a:buChar char="•"/>
             </a:pPr>
             <a:r>
-              <a:rPr lang="en-US" sz="1700" dirty="0">
+              <a:rPr lang="en-US" sz="1600" dirty="0">
                 <a:solidFill>
                   <a:srgbClr val="16233A"/>
                 </a:solidFill>
@@ -4571,20 +4571,20 @@
                 <a:ea typeface="Calibri" pitchFamily="34" charset="-122"/>
                 <a:cs typeface="Calibri" pitchFamily="34" charset="-120"/>
               </a:rPr>
-              <a:t>Custom agents: *.agent.md</a:t>
-            </a:r>
-            <a:endParaRPr lang="en-US" sz="1700" dirty="0"/>
+              <a:t>Custom agents: *.agent.md · Hooks: hooks.json · MCP: .mcp.json</a:t>
+            </a:r>
+            <a:endParaRPr lang="en-US" sz="1600" dirty="0"/>
           </a:p>
           <a:p>
             <a:pPr marL="203200" indent="-203200">
               <a:spcAft>
-                <a:spcPts val="1100"/>
+                <a:spcPts val="900"/>
               </a:spcAft>
               <a:buSzPct val="100000"/>
               <a:buChar char="•"/>
             </a:pPr>
             <a:r>
-              <a:rPr lang="en-US" sz="1700" dirty="0">
+              <a:rPr lang="en-US" sz="1600" dirty="0">
                 <a:solidFill>
                   <a:srgbClr val="16233A"/>
                 </a:solidFill>
@@ -4592,20 +4592,20 @@
                 <a:ea typeface="Calibri" pitchFamily="34" charset="-122"/>
                 <a:cs typeface="Calibri" pitchFamily="34" charset="-120"/>
               </a:rPr>
-              <a:t>Hooks: hooks.json · MCP: .mcp.json / mcp.json</a:t>
-            </a:r>
-            <a:endParaRPr lang="en-US" sz="1700" dirty="0"/>
+              <a:t>A marketplace = a repo with marketplace.json under .github/plugin.</a:t>
+            </a:r>
+            <a:endParaRPr lang="en-US" sz="1600" dirty="0"/>
           </a:p>
           <a:p>
             <a:pPr marL="203200" indent="-203200">
               <a:spcAft>
-                <a:spcPts val="1100"/>
+                <a:spcPts val="900"/>
               </a:spcAft>
               <a:buSzPct val="100000"/>
               <a:buChar char="•"/>
             </a:pPr>
             <a:r>
-              <a:rPr lang="en-US" sz="1700" dirty="0">
+              <a:rPr lang="en-US" sz="1600" dirty="0">
                 <a:solidFill>
                   <a:srgbClr val="16233A"/>
                 </a:solidFill>
@@ -4613,20 +4613,172 @@
                 <a:ea typeface="Calibri" pitchFamily="34" charset="-122"/>
                 <a:cs typeface="Calibri" pitchFamily="34" charset="-120"/>
               </a:rPr>
-              <a:t>Install: /plugin install owner/repo (Copilot CLI; repo must be a marketplace).</a:t>
-            </a:r>
-            <a:endParaRPr lang="en-US" sz="1700" dirty="0"/>
-          </a:p>
-          <a:p>
-            <a:pPr marL="203200" indent="-203200">
-              <a:spcAft>
-                <a:spcPts val="1100"/>
-              </a:spcAft>
-              <a:buSzPct val="100000"/>
-              <a:buChar char="•"/>
-            </a:pPr>
-            <a:r>
-              <a:rPr lang="en-US" sz="1700" dirty="0">
+              <a:t>Install from one (Copilot CLI) — PLUGIN@MARKETPLACE:</a:t>
+            </a:r>
+            <a:endParaRPr lang="en-US" sz="1600" dirty="0"/>
+          </a:p>
+        </p:txBody>
+      </p:sp>
+      <p:sp>
+        <p:nvSpPr>
+          <p:cNvPr id="5" name="Shape 3"/>
+          <p:cNvSpPr/>
+          <p:nvPr/>
+        </p:nvSpPr>
+        <p:spPr>
+          <a:xfrm>
+            <a:off x="548640" y="3429000"/>
+            <a:ext cx="11094415" cy="1417320"/>
+          </a:xfrm>
+          <a:prstGeom prst="roundRect">
+            <a:avLst>
+              <a:gd name="adj" fmla="val 3226"/>
+            </a:avLst>
+          </a:prstGeom>
+          <a:solidFill>
+            <a:srgbClr val="0D1B2E"/>
+          </a:solidFill>
+          <a:ln w="15875">
+            <a:solidFill>
+              <a:srgbClr val="00A3A3"/>
+            </a:solidFill>
+            <a:prstDash val="solid"/>
+          </a:ln>
+        </p:spPr>
+      </p:sp>
+      <p:sp>
+        <p:nvSpPr>
+          <p:cNvPr id="6" name="Text 4"/>
+          <p:cNvSpPr/>
+          <p:nvPr/>
+        </p:nvSpPr>
+        <p:spPr>
+          <a:xfrm>
+            <a:off x="676656" y="3474720"/>
+            <a:ext cx="10838383" cy="1325880"/>
+          </a:xfrm>
+          <a:prstGeom prst="rect">
+            <a:avLst/>
+          </a:prstGeom>
+          <a:noFill/>
+          <a:ln/>
+        </p:spPr>
+        <p:txBody>
+          <a:bodyPr wrap="square" lIns="0" tIns="0" rIns="0" bIns="0" rtlCol="0" anchor="ctr"/>
+          <a:lstStyle/>
+          <a:p>
+            <a:pPr algn="l" indent="0" marL="0">
+              <a:buNone/>
+            </a:pPr>
+            <a:r>
+              <a:rPr lang="en-US" sz="1100" dirty="0">
+                <a:solidFill>
+                  <a:srgbClr val="E8F0FF"/>
+                </a:solidFill>
+                <a:latin typeface="Consolas" pitchFamily="34" charset="0"/>
+                <a:ea typeface="Consolas" pitchFamily="34" charset="-122"/>
+                <a:cs typeface="Consolas" pitchFamily="34" charset="-120"/>
+              </a:rPr>
+              <a:t>/plugin marketplace add amilos/agentic-coding-101-marketplace</a:t>
+            </a:r>
+            <a:endParaRPr lang="en-US" sz="1100" dirty="0"/>
+          </a:p>
+          <a:p>
+            <a:pPr algn="l" indent="0" marL="0">
+              <a:buNone/>
+            </a:pPr>
+            <a:r>
+              <a:rPr lang="en-US" sz="1100" dirty="0">
+                <a:solidFill>
+                  <a:srgbClr val="E8F0FF"/>
+                </a:solidFill>
+                <a:latin typeface="Consolas" pitchFamily="34" charset="0"/>
+                <a:ea typeface="Consolas" pitchFamily="34" charset="-122"/>
+                <a:cs typeface="Consolas" pitchFamily="34" charset="-120"/>
+              </a:rPr>
+              <a:t>/plugin install addyosmani-agent-skills@agentic-coding-101-marketplace</a:t>
+            </a:r>
+            <a:endParaRPr lang="en-US" sz="1100" dirty="0"/>
+          </a:p>
+          <a:p>
+            <a:pPr algn="l" indent="0" marL="0">
+              <a:buNone/>
+            </a:pPr>
+            <a:r>
+              <a:rPr lang="en-US" sz="1100" dirty="0">
+                <a:solidFill>
+                  <a:srgbClr val="E8F0FF"/>
+                </a:solidFill>
+                <a:latin typeface="Consolas" pitchFamily="34" charset="0"/>
+                <a:ea typeface="Consolas" pitchFamily="34" charset="-122"/>
+                <a:cs typeface="Consolas" pitchFamily="34" charset="-120"/>
+              </a:rPr>
+              <a:t>/plugin install mattpocock-skills@agentic-coding-101-marketplace</a:t>
+            </a:r>
+            <a:endParaRPr lang="en-US" sz="1100" dirty="0"/>
+          </a:p>
+        </p:txBody>
+      </p:sp>
+      <p:sp>
+        <p:nvSpPr>
+          <p:cNvPr id="7" name="Shape 5"/>
+          <p:cNvSpPr/>
+          <p:nvPr/>
+        </p:nvSpPr>
+        <p:spPr>
+          <a:xfrm>
+            <a:off x="548640" y="5074920"/>
+            <a:ext cx="11094415" cy="960120"/>
+          </a:xfrm>
+          <a:prstGeom prst="roundRect">
+            <a:avLst>
+              <a:gd name="adj" fmla="val 7619"/>
+            </a:avLst>
+          </a:prstGeom>
+          <a:solidFill>
+            <a:srgbClr val="F3F7FF"/>
+          </a:solidFill>
+          <a:ln w="12700">
+            <a:solidFill>
+              <a:srgbClr val="D6E2F7"/>
+            </a:solidFill>
+            <a:prstDash val="solid"/>
+          </a:ln>
+          <a:effectLst>
+            <a:outerShdw sx="100000" sy="100000" kx="0" ky="0" algn="bl" rotWithShape="0" blurRad="76200" dist="25400" dir="5400000">
+              <a:srgbClr val="8AA0C0">
+                <a:alpha val="22000"/>
+              </a:srgbClr>
+            </a:outerShdw>
+          </a:effectLst>
+        </p:spPr>
+      </p:sp>
+      <p:sp>
+        <p:nvSpPr>
+          <p:cNvPr id="8" name="Text 6"/>
+          <p:cNvSpPr/>
+          <p:nvPr/>
+        </p:nvSpPr>
+        <p:spPr>
+          <a:xfrm>
+            <a:off x="713232" y="5239512"/>
+            <a:ext cx="10765231" cy="630936"/>
+          </a:xfrm>
+          <a:prstGeom prst="rect">
+            <a:avLst/>
+          </a:prstGeom>
+          <a:noFill/>
+          <a:ln/>
+        </p:spPr>
+        <p:txBody>
+          <a:bodyPr wrap="square" lIns="0" tIns="0" rIns="0" bIns="0" rtlCol="0" anchor="ctr"/>
+          <a:lstStyle/>
+          <a:p>
+            <a:pPr algn="l" indent="0" marL="0">
+              <a:buNone/>
+            </a:pPr>
+            <a:r>
+              <a:rPr lang="en-US" sz="1300" dirty="0">
                 <a:solidFill>
                   <a:srgbClr val="16233A"/>
                 </a:solidFill>
@@ -4634,9 +4786,9 @@
                 <a:ea typeface="Calibri" pitchFamily="34" charset="-122"/>
                 <a:cs typeface="Calibri" pitchFamily="34" charset="-120"/>
               </a:rPr>
-              <a:t>App enables plugins via .github/copilot/settings.json.</a:t>
-            </a:r>
-            <a:endParaRPr lang="en-US" sz="1700" dirty="0"/>
+              <a:t>Course marketplace bundles Addy Osmani's (24) + Matt Pocock's (39) skills as two plugins — MIT, redistributed with attribution.</a:t>
+            </a:r>
+            <a:endParaRPr lang="en-US" sz="1300" dirty="0"/>
           </a:p>
         </p:txBody>
       </p:sp>

</xml_diff>

<commit_message>
§5 marketplace demo now uses the Copilot app GUI, not the CLI
The focus is the GitHub Copilot app. Corrected every place to the verified GUI flow:
Settings → Plugins → Install → Add Marketplace → amilos/agentic-coding-101-marketplace
→ click Install on addyosmani-agent-skills and mattpocock-skills.

Removed the CLI-first framing from the trainer guide (prep, concepts table, §5c live
moment, troubleshooting), slides (HTML + PPTX, kept 1:1 — 245/245 verbatim) and
cheat-sheet (md+html). Copy-into-.github/skills/ remains the offline fallback.

Co-Authored-By: Claude Opus 4.8 <noreply@anthropic.com>
</commit_message>
<xml_diff>
--- a/slides/agentic-coding-101.pptx
+++ b/slides/agentic-coding-101.pptx
@@ -710,7 +710,7 @@
           <a:p>
             <a:r>
               <a:rPr lang="en-US" dirty="0"/>
-              <a:t>We publish a real marketplace, amilos/agentic-coding-101-marketplace, bundling Addy Osmani's (24) and Matt Pocock's (39) skills as two plugins — MIT, redistributed with attribution. Two commands and every session in the repo gains ~60 community skills. A plain skills repo is NOT a marketplace (no marketplace.json), which is why /plugin install owner/repo fails for those. The app can also enable plugins declaratively via .github/copilot/settings.json. The demo-repo ships a sample security-reviewer.agent.md to show the shape of a custom agent.</a:t>
+              <a:t>We publish a real marketplace, amilos/agentic-coding-101-marketplace, bundling Addy Osmani's (24) and Matt Pocock's (39) skills as two plugins — MIT, redistributed with attribution. Do it live in the app GUI: Settings → Plugins → Install → Add Marketplace, enter the owner/repo, then click Install on each listed plugin. A plain skills repo is NOT a marketplace (no marketplace.json), so it will not show up here. A few clicks and every session in the repo gains ~60 community skills. The demo-repo ships a sample security-reviewer.agent.md to show the shape of a custom agent.</a:t>
             </a:r>
             <a:endParaRPr lang="en-US" dirty="0"/>
           </a:p>
@@ -4613,7 +4613,7 @@
                 <a:ea typeface="Calibri" pitchFamily="34" charset="-122"/>
                 <a:cs typeface="Calibri" pitchFamily="34" charset="-120"/>
               </a:rPr>
-              <a:t>Install from one (Copilot CLI) — PLUGIN@MARKETPLACE:</a:t>
+              <a:t>Add &amp; install right in the app — Settings → Plugins:</a:t>
             </a:r>
             <a:endParaRPr lang="en-US" sz="1600" dirty="0"/>
           </a:p>
@@ -4679,7 +4679,7 @@
                 <a:ea typeface="Consolas" pitchFamily="34" charset="-122"/>
                 <a:cs typeface="Consolas" pitchFamily="34" charset="-120"/>
               </a:rPr>
-              <a:t>/plugin marketplace add amilos/agentic-coding-101-marketplace</a:t>
+              <a:t>Settings → Plugins → Install → Add Marketplace</a:t>
             </a:r>
             <a:endParaRPr lang="en-US" sz="1100" dirty="0"/>
           </a:p>
@@ -4696,7 +4696,7 @@
                 <a:ea typeface="Consolas" pitchFamily="34" charset="-122"/>
                 <a:cs typeface="Consolas" pitchFamily="34" charset="-120"/>
               </a:rPr>
-              <a:t>/plugin install addyosmani-agent-skills@agentic-coding-101-marketplace</a:t>
+              <a:t>   amilos/agentic-coding-101-marketplace</a:t>
             </a:r>
             <a:endParaRPr lang="en-US" sz="1100" dirty="0"/>
           </a:p>
@@ -4713,7 +4713,24 @@
                 <a:ea typeface="Consolas" pitchFamily="34" charset="-122"/>
                 <a:cs typeface="Consolas" pitchFamily="34" charset="-120"/>
               </a:rPr>
-              <a:t>/plugin install mattpocock-skills@agentic-coding-101-marketplace</a:t>
+              <a:t>→ Install:  addyosmani-agent-skills</a:t>
+            </a:r>
+            <a:endParaRPr lang="en-US" sz="1100" dirty="0"/>
+          </a:p>
+          <a:p>
+            <a:pPr algn="l" indent="0" marL="0">
+              <a:buNone/>
+            </a:pPr>
+            <a:r>
+              <a:rPr lang="en-US" sz="1100" dirty="0">
+                <a:solidFill>
+                  <a:srgbClr val="E8F0FF"/>
+                </a:solidFill>
+                <a:latin typeface="Consolas" pitchFamily="34" charset="0"/>
+                <a:ea typeface="Consolas" pitchFamily="34" charset="-122"/>
+                <a:cs typeface="Consolas" pitchFamily="34" charset="-120"/>
+              </a:rPr>
+              <a:t>→ Install:  mattpocock-skills</a:t>
             </a:r>
             <a:endParaRPr lang="en-US" sz="1100" dirty="0"/>
           </a:p>

</xml_diff>

<commit_message>
OpenSpec: live in the demo repo, seeded from a GH issue (idempotent transfers)
Fixes the advanced segment's continuity and structure:

- Remove the artificial standalone openspec-demo/ folder. OpenSpec now lives
  inside demo-repo/ next to the code: openspec/project.md +
  .github/prompts/openspec-*.prompt.md + docs/adr/0001-idempotent-transfers.md.
- Change is add-idempotent-transfers (was add-transfer-limit, which the stations
  already build & merge, so it can't be the OpenSpec change). It's the feature
  Station 2's ADR designed but never built — seeded from GitHub issue #6.
- Clarify the starting point: demo repo main with the limit shipped and OpenSpec
  initialised; openspec/changes/ empty; propose reads the issue. The pre-baked
  change is on the demo repo's `openspec` branch (fallback).
- Updated trainer-guide, workbook, slides (HTML + PPTX), cheat-sheet, README;
  regenerated the PPTX (HTML↔PPTX verbatim).

Co-Authored-By: Claude Opus 4.8 <noreply@anthropic.com>
</commit_message>
<xml_diff>
--- a/slides/agentic-coding-101.pptx
+++ b/slides/agentic-coding-101.pptx
@@ -2646,7 +2646,7 @@
           <a:p>
             <a:r>
               <a:rPr lang="en-US" dirty="0"/>
-              <a:t>OpenSpec (Fission-AI) is lightweight and brownfield-first; the propose/apply/archive verbs appear as slash-command prompt files. Spec Kit (github/spec-kit) is the heavier, template-driven, agent-agnostic alternative. Position them as two points on a spectrum, not competitors. Reuse add-transfer-limit so it mirrors the station work.</a:t>
+              <a:t>OpenSpec (Fission-AI) is lightweight and brownfield-first; the propose/apply/archive verbs appear as slash-command prompt files. Spec Kit (github/spec-kit) is the heavier, template-driven, agent-agnostic alternative. Starting point: the repo is OpenSpec-initialised and the daily limit is already shipped, so we build the next unbuilt feature — idempotent transfers, designed in Station 2's ADR 0001 and filed as issue #6; openspec propose reads that issue. Fallback: the pre-baked change on the demo repo's openspec branch.</a:t>
             </a:r>
             <a:endParaRPr lang="en-US" dirty="0"/>
           </a:p>
@@ -11588,7 +11588,7 @@
                 <a:ea typeface="Consolas" pitchFamily="34" charset="-122"/>
                 <a:cs typeface="Consolas" pitchFamily="34" charset="-120"/>
               </a:rPr>
-              <a:t>openspec propose add-transfer-limit</a:t>
+              <a:t>openspec propose add-idempotent-transfers</a:t>
             </a:r>
             <a:endParaRPr lang="en-US" sz="1100" dirty="0"/>
           </a:p>
@@ -11622,7 +11622,7 @@
                 <a:ea typeface="Consolas" pitchFamily="34" charset="-122"/>
                 <a:cs typeface="Consolas" pitchFamily="34" charset="-120"/>
               </a:rPr>
-              <a:t>openspec apply  add-transfer-limit</a:t>
+              <a:t>openspec apply  add-idempotent-transfers</a:t>
             </a:r>
             <a:endParaRPr lang="en-US" sz="1100" dirty="0"/>
           </a:p>
@@ -11639,7 +11639,7 @@
                 <a:ea typeface="Consolas" pitchFamily="34" charset="-122"/>
                 <a:cs typeface="Consolas" pitchFamily="34" charset="-120"/>
               </a:rPr>
-              <a:t>openspec archive add-transfer-limit</a:t>
+              <a:t>openspec archive add-idempotent-transfers</a:t>
             </a:r>
             <a:endParaRPr lang="en-US" sz="1100" dirty="0"/>
           </a:p>

</xml_diff>